<commit_message>
Ground market slide with sourced figures; target market >EUR 1bn
Rework the market slide with real data (OMI/Agenzia delle Entrate 2024,
Il Sole 24 Ore, EPBD/Case Green estimates): ~720k residential
transactions/yr, EUR 2.8bn brokerage / EUR 36bn real-estate services,
EUR 85bn Case Green investment by 2030. Reframe SAM as multi-billion and
SOM as a beachhead, and add the EUR 85bn figure to the 'why now' slide.

Co-Authored-By: Claude Opus 4.8 <noreply@anthropic.com>
Claude-Session: https://claude.ai/code/session_0135g8yviycycMotcppH6TXW
</commit_message>
<xml_diff>
--- a/proptech-deck/Conforme_Pitch.pptx
+++ b/proptech-deck/Conforme_Pitch.pptx
@@ -5709,7 +5709,7 @@
                 <a:ea typeface="Cambria" pitchFamily="34" charset="-122"/>
                 <a:cs typeface="Cambria" pitchFamily="34" charset="-120"/>
               </a:rPr>
-              <a:t>~75%</a:t>
+              <a:t>~720.000</a:t>
             </a:r>
             <a:endParaRPr lang="en-US" sz="4400" dirty="0"/>
           </a:p>
@@ -5748,7 +5748,7 @@
                 <a:ea typeface="Calibri" pitchFamily="34" charset="-122"/>
                 <a:cs typeface="Calibri" pitchFamily="34" charset="-120"/>
               </a:rPr>
-              <a:t>tra i più alti tassi di proprietà della casa in Europa: un patrimonio enorme e frammentato</a:t>
+              <a:t>compravendite residenziali all'anno in Italia (OMI 2024)</a:t>
             </a:r>
             <a:endParaRPr lang="en-US" sz="1400" dirty="0"/>
           </a:p>
@@ -5919,7 +5919,7 @@
                 <a:ea typeface="Cambria" pitchFamily="34" charset="-122"/>
                 <a:cs typeface="Cambria" pitchFamily="34" charset="-120"/>
               </a:rPr>
-              <a:t>~€100 mld+</a:t>
+              <a:t>~€120 mld</a:t>
             </a:r>
             <a:endParaRPr lang="en-US" sz="4400" dirty="0"/>
           </a:p>
@@ -5958,7 +5958,7 @@
                 <a:ea typeface="Calibri" pitchFamily="34" charset="-122"/>
                 <a:cs typeface="Calibri" pitchFamily="34" charset="-120"/>
               </a:rPr>
-              <a:t>volume annuo delle compravendite residenziali (ordine di grandezza)</a:t>
+              <a:t>transato residenziale all'anno (ordine di grandezza)</a:t>
             </a:r>
             <a:endParaRPr lang="en-US" sz="1400" dirty="0"/>
           </a:p>
@@ -6012,7 +6012,7 @@
         <p:spPr>
           <a:xfrm>
             <a:off x="502920" y="5989320"/>
-            <a:ext cx="7315200" cy="274320"/>
+            <a:ext cx="10058400" cy="274320"/>
           </a:xfrm>
           <a:prstGeom prst="rect">
             <a:avLst/>
@@ -6036,7 +6036,7 @@
                 <a:ea typeface="Calibri" pitchFamily="34" charset="-122"/>
                 <a:cs typeface="Calibri" pitchFamily="34" charset="-120"/>
               </a:rPr>
-              <a:t>Cifre a livello di mercato, indicative / ordine di grandezza.</a:t>
+              <a:t>Fonte compravendite: OMI — Agenzia delle Entrate, Rapporto Immobiliare 2025. Transato: stima / ordine di grandezza.</a:t>
             </a:r>
             <a:endParaRPr lang="en-US" sz="1000" dirty="0"/>
           </a:p>
@@ -9090,7 +9090,7 @@
         </p:nvSpPr>
         <p:spPr>
           <a:xfrm>
-            <a:off x="548640" y="502920"/>
+            <a:off x="548640" y="457200"/>
             <a:ext cx="5486400" cy="274320"/>
           </a:xfrm>
           <a:prstGeom prst="rect">
@@ -9129,8 +9129,8 @@
         </p:nvSpPr>
         <p:spPr>
           <a:xfrm>
-            <a:off x="502920" y="822960"/>
-            <a:ext cx="11155680" cy="731520"/>
+            <a:off x="502920" y="749808"/>
+            <a:ext cx="11155680" cy="548640"/>
           </a:xfrm>
           <a:prstGeom prst="rect">
             <a:avLst/>
@@ -9146,7 +9146,7 @@
               <a:buNone/>
             </a:pPr>
             <a:r>
-              <a:rPr lang="en-US" sz="2600" b="1" dirty="0">
+              <a:rPr lang="en-US" sz="2700" b="1" dirty="0">
                 <a:solidFill>
                   <a:srgbClr val="16233B"/>
                 </a:solidFill>
@@ -9154,26 +9154,65 @@
                 <a:ea typeface="Cambria" pitchFamily="34" charset="-122"/>
                 <a:cs typeface="Cambria" pitchFamily="34" charset="-120"/>
               </a:rPr>
-              <a:t>Un mercato enorme, con un punto d'ingresso stretto e monetizzabile subito</a:t>
-            </a:r>
-            <a:endParaRPr lang="en-US" sz="2600" dirty="0"/>
-          </a:p>
-        </p:txBody>
-      </p:sp>
-      <p:sp>
-        <p:nvSpPr>
-          <p:cNvPr id="4" name="Shape 2"/>
-          <p:cNvSpPr/>
-          <p:nvPr/>
-        </p:nvSpPr>
-        <p:spPr>
-          <a:xfrm>
-            <a:off x="502920" y="2148840"/>
-            <a:ext cx="5120640" cy="1143000"/>
+              <a:t>Il mercato target supera il miliardo — di molto</a:t>
+            </a:r>
+            <a:endParaRPr lang="en-US" sz="2700" dirty="0"/>
+          </a:p>
+        </p:txBody>
+      </p:sp>
+      <p:sp>
+        <p:nvSpPr>
+          <p:cNvPr id="4" name="Text 2"/>
+          <p:cNvSpPr/>
+          <p:nvPr/>
+        </p:nvSpPr>
+        <p:spPr>
+          <a:xfrm>
+            <a:off x="502920" y="1298448"/>
+            <a:ext cx="11155680" cy="502920"/>
+          </a:xfrm>
+          <a:prstGeom prst="rect">
+            <a:avLst/>
+          </a:prstGeom>
+          <a:noFill/>
+          <a:ln/>
+        </p:spPr>
+        <p:txBody>
+          <a:bodyPr wrap="square" lIns="0" tIns="0" rIns="0" bIns="0" rtlCol="0" anchor="ctr"/>
+          <a:lstStyle/>
+          <a:p>
+            <a:pPr indent="0" marL="0">
+              <a:buNone/>
+            </a:pPr>
+            <a:r>
+              <a:rPr lang="en-US" sz="1450" dirty="0">
+                <a:solidFill>
+                  <a:srgbClr val="5C6C87"/>
+                </a:solidFill>
+                <a:latin typeface="Calibri" pitchFamily="34" charset="0"/>
+                <a:ea typeface="Calibri" pitchFamily="34" charset="-122"/>
+                <a:cs typeface="Calibri" pitchFamily="34" charset="-120"/>
+              </a:rPr>
+              <a:t>La sola due diligence tecnico-legale vale ~€1 mld/anno. Con i servizi alla transazione e l'ondata Case Green, il target è multi-miliardo.</a:t>
+            </a:r>
+            <a:endParaRPr lang="en-US" sz="1450" dirty="0"/>
+          </a:p>
+        </p:txBody>
+      </p:sp>
+      <p:sp>
+        <p:nvSpPr>
+          <p:cNvPr id="5" name="Shape 3"/>
+          <p:cNvSpPr/>
+          <p:nvPr/>
+        </p:nvSpPr>
+        <p:spPr>
+          <a:xfrm>
+            <a:off x="502920" y="1965960"/>
+            <a:ext cx="7863840" cy="1188720"/>
           </a:xfrm>
           <a:prstGeom prst="roundRect">
             <a:avLst>
-              <a:gd name="adj" fmla="val 7200"/>
+              <a:gd name="adj" fmla="val 6923"/>
             </a:avLst>
           </a:prstGeom>
           <a:solidFill>
@@ -9184,14 +9223,14 @@
       </p:sp>
       <p:sp>
         <p:nvSpPr>
-          <p:cNvPr id="5" name="Text 3"/>
-          <p:cNvSpPr/>
-          <p:nvPr/>
-        </p:nvSpPr>
-        <p:spPr>
-          <a:xfrm>
-            <a:off x="731520" y="2313432"/>
-            <a:ext cx="1463040" cy="822960"/>
+          <p:cNvPr id="6" name="Text 4"/>
+          <p:cNvSpPr/>
+          <p:nvPr/>
+        </p:nvSpPr>
+        <p:spPr>
+          <a:xfrm>
+            <a:off x="731520" y="2103120"/>
+            <a:ext cx="1371600" cy="914400"/>
           </a:xfrm>
           <a:prstGeom prst="rect">
             <a:avLst/>
@@ -9223,14 +9262,14 @@
       </p:sp>
       <p:sp>
         <p:nvSpPr>
-          <p:cNvPr id="6" name="Text 4"/>
-          <p:cNvSpPr/>
-          <p:nvPr/>
-        </p:nvSpPr>
-        <p:spPr>
-          <a:xfrm>
-            <a:off x="2103120" y="2331720"/>
-            <a:ext cx="3566160" cy="457200"/>
+          <p:cNvPr id="7" name="Text 5"/>
+          <p:cNvSpPr/>
+          <p:nvPr/>
+        </p:nvSpPr>
+        <p:spPr>
+          <a:xfrm>
+            <a:off x="2057400" y="2167128"/>
+            <a:ext cx="6355080" cy="457200"/>
           </a:xfrm>
           <a:prstGeom prst="rect">
             <a:avLst/>
@@ -9246,7 +9285,7 @@
               <a:buNone/>
             </a:pPr>
             <a:r>
-              <a:rPr lang="en-US" sz="1600" b="1" dirty="0">
+              <a:rPr lang="en-US" sz="1700" b="1" dirty="0">
                 <a:solidFill>
                   <a:srgbClr val="FFFFFF"/>
                 </a:solidFill>
@@ -9254,22 +9293,22 @@
                 <a:ea typeface="Cambria" pitchFamily="34" charset="-122"/>
                 <a:cs typeface="Cambria" pitchFamily="34" charset="-120"/>
               </a:rPr>
-              <a:t>~€100 mld+ transato/anno</a:t>
-            </a:r>
-            <a:endParaRPr lang="en-US" sz="1600" dirty="0"/>
-          </a:p>
-        </p:txBody>
-      </p:sp>
-      <p:sp>
-        <p:nvSpPr>
-          <p:cNvPr id="7" name="Text 5"/>
-          <p:cNvSpPr/>
-          <p:nvPr/>
-        </p:nvSpPr>
-        <p:spPr>
-          <a:xfrm>
-            <a:off x="2103120" y="2770632"/>
-            <a:ext cx="4114800" cy="457200"/>
+              <a:t>~€120 mld transato residenziale/anno + €280 mld di giro d'affari Case Green potenziale</a:t>
+            </a:r>
+            <a:endParaRPr lang="en-US" sz="1700" dirty="0"/>
+          </a:p>
+        </p:txBody>
+      </p:sp>
+      <p:sp>
+        <p:nvSpPr>
+          <p:cNvPr id="8" name="Text 6"/>
+          <p:cNvSpPr/>
+          <p:nvPr/>
+        </p:nvSpPr>
+        <p:spPr>
+          <a:xfrm>
+            <a:off x="2057400" y="2624328"/>
+            <a:ext cx="6355080" cy="457200"/>
           </a:xfrm>
           <a:prstGeom prst="rect">
             <a:avLst/>
@@ -9287,13 +9326,13 @@
             <a:r>
               <a:rPr lang="en-US" sz="1250" dirty="0">
                 <a:solidFill>
-                  <a:srgbClr val="FFFFFF"/>
+                  <a:srgbClr val="EAF1FA"/>
                 </a:solidFill>
                 <a:latin typeface="Calibri" pitchFamily="34" charset="0"/>
                 <a:ea typeface="Calibri" pitchFamily="34" charset="-122"/>
                 <a:cs typeface="Calibri" pitchFamily="34" charset="-120"/>
               </a:rPr>
-              <a:t>Mercato immobiliare &amp; servizi collegati in Italia</a:t>
+              <a:t>Mercato immobiliare &amp; riqualificazione in Italia</a:t>
             </a:r>
             <a:endParaRPr lang="en-US" sz="1250" dirty="0"/>
           </a:p>
@@ -9301,18 +9340,18 @@
       </p:sp>
       <p:sp>
         <p:nvSpPr>
-          <p:cNvPr id="8" name="Shape 6"/>
-          <p:cNvSpPr/>
-          <p:nvPr/>
-        </p:nvSpPr>
-        <p:spPr>
-          <a:xfrm>
-            <a:off x="502920" y="3474720"/>
-            <a:ext cx="3840480" cy="1143000"/>
+          <p:cNvPr id="9" name="Shape 7"/>
+          <p:cNvSpPr/>
+          <p:nvPr/>
+        </p:nvSpPr>
+        <p:spPr>
+          <a:xfrm>
+            <a:off x="502920" y="3337560"/>
+            <a:ext cx="6035040" cy="1188720"/>
           </a:xfrm>
           <a:prstGeom prst="roundRect">
             <a:avLst>
-              <a:gd name="adj" fmla="val 7200"/>
+              <a:gd name="adj" fmla="val 6923"/>
             </a:avLst>
           </a:prstGeom>
           <a:solidFill>
@@ -9323,14 +9362,14 @@
       </p:sp>
       <p:sp>
         <p:nvSpPr>
-          <p:cNvPr id="9" name="Text 7"/>
-          <p:cNvSpPr/>
-          <p:nvPr/>
-        </p:nvSpPr>
-        <p:spPr>
-          <a:xfrm>
-            <a:off x="731520" y="3639312"/>
-            <a:ext cx="1463040" cy="822960"/>
+          <p:cNvPr id="10" name="Text 8"/>
+          <p:cNvSpPr/>
+          <p:nvPr/>
+        </p:nvSpPr>
+        <p:spPr>
+          <a:xfrm>
+            <a:off x="731520" y="3474720"/>
+            <a:ext cx="1371600" cy="914400"/>
           </a:xfrm>
           <a:prstGeom prst="rect">
             <a:avLst/>
@@ -9362,14 +9401,14 @@
       </p:sp>
       <p:sp>
         <p:nvSpPr>
-          <p:cNvPr id="10" name="Text 8"/>
-          <p:cNvSpPr/>
-          <p:nvPr/>
-        </p:nvSpPr>
-        <p:spPr>
-          <a:xfrm>
-            <a:off x="2103120" y="3657600"/>
-            <a:ext cx="2286000" cy="457200"/>
+          <p:cNvPr id="11" name="Text 9"/>
+          <p:cNvSpPr/>
+          <p:nvPr/>
+        </p:nvSpPr>
+        <p:spPr>
+          <a:xfrm>
+            <a:off x="2057400" y="3538728"/>
+            <a:ext cx="4526280" cy="457200"/>
           </a:xfrm>
           <a:prstGeom prst="rect">
             <a:avLst/>
@@ -9385,7 +9424,7 @@
               <a:buNone/>
             </a:pPr>
             <a:r>
-              <a:rPr lang="en-US" sz="1600" b="1" dirty="0">
+              <a:rPr lang="en-US" sz="1700" b="1" dirty="0">
                 <a:solidFill>
                   <a:srgbClr val="FFFFFF"/>
                 </a:solidFill>
@@ -9393,22 +9432,22 @@
                 <a:ea typeface="Cambria" pitchFamily="34" charset="-122"/>
                 <a:cs typeface="Cambria" pitchFamily="34" charset="-120"/>
               </a:rPr>
-              <a:t>Miliardi di € di spesa annua</a:t>
-            </a:r>
-            <a:endParaRPr lang="en-US" sz="1600" dirty="0"/>
-          </a:p>
-        </p:txBody>
-      </p:sp>
-      <p:sp>
-        <p:nvSpPr>
-          <p:cNvPr id="11" name="Text 9"/>
-          <p:cNvSpPr/>
-          <p:nvPr/>
-        </p:nvSpPr>
-        <p:spPr>
-          <a:xfrm>
-            <a:off x="2103120" y="4096512"/>
-            <a:ext cx="4114800" cy="457200"/>
+              <a:t>Multi-miliardo € / anno</a:t>
+            </a:r>
+            <a:endParaRPr lang="en-US" sz="1700" dirty="0"/>
+          </a:p>
+        </p:txBody>
+      </p:sp>
+      <p:sp>
+        <p:nvSpPr>
+          <p:cNvPr id="12" name="Text 10"/>
+          <p:cNvSpPr/>
+          <p:nvPr/>
+        </p:nvSpPr>
+        <p:spPr>
+          <a:xfrm>
+            <a:off x="2057400" y="3995928"/>
+            <a:ext cx="4526280" cy="457200"/>
           </a:xfrm>
           <a:prstGeom prst="rect">
             <a:avLst/>
@@ -9426,13 +9465,13 @@
             <a:r>
               <a:rPr lang="en-US" sz="1250" dirty="0">
                 <a:solidFill>
-                  <a:srgbClr val="FFFFFF"/>
+                  <a:srgbClr val="F6E4DE"/>
                 </a:solidFill>
                 <a:latin typeface="Calibri" pitchFamily="34" charset="0"/>
                 <a:ea typeface="Calibri" pitchFamily="34" charset="-122"/>
                 <a:cs typeface="Calibri" pitchFamily="34" charset="-120"/>
               </a:rPr>
-              <a:t>Due diligence, valutazione e servizi di transazione</a:t>
+              <a:t>Servizi tecnico-legali, valutazione e intelligence energetica digitalizzabili</a:t>
             </a:r>
             <a:endParaRPr lang="en-US" sz="1250" dirty="0"/>
           </a:p>
@@ -9440,18 +9479,18 @@
       </p:sp>
       <p:sp>
         <p:nvSpPr>
-          <p:cNvPr id="12" name="Shape 10"/>
-          <p:cNvSpPr/>
-          <p:nvPr/>
-        </p:nvSpPr>
-        <p:spPr>
-          <a:xfrm>
-            <a:off x="502920" y="4800600"/>
-            <a:ext cx="2560320" cy="1143000"/>
+          <p:cNvPr id="13" name="Shape 11"/>
+          <p:cNvSpPr/>
+          <p:nvPr/>
+        </p:nvSpPr>
+        <p:spPr>
+          <a:xfrm>
+            <a:off x="502920" y="4709160"/>
+            <a:ext cx="4206240" cy="1188720"/>
           </a:xfrm>
           <a:prstGeom prst="roundRect">
             <a:avLst>
-              <a:gd name="adj" fmla="val 7200"/>
+              <a:gd name="adj" fmla="val 6923"/>
             </a:avLst>
           </a:prstGeom>
           <a:solidFill>
@@ -9462,14 +9501,14 @@
       </p:sp>
       <p:sp>
         <p:nvSpPr>
-          <p:cNvPr id="13" name="Text 11"/>
-          <p:cNvSpPr/>
-          <p:nvPr/>
-        </p:nvSpPr>
-        <p:spPr>
-          <a:xfrm>
-            <a:off x="731520" y="4965192"/>
-            <a:ext cx="1463040" cy="822960"/>
+          <p:cNvPr id="14" name="Text 12"/>
+          <p:cNvSpPr/>
+          <p:nvPr/>
+        </p:nvSpPr>
+        <p:spPr>
+          <a:xfrm>
+            <a:off x="731520" y="4846320"/>
+            <a:ext cx="1371600" cy="914400"/>
           </a:xfrm>
           <a:prstGeom prst="rect">
             <a:avLst/>
@@ -9501,14 +9540,14 @@
       </p:sp>
       <p:sp>
         <p:nvSpPr>
-          <p:cNvPr id="14" name="Text 12"/>
-          <p:cNvSpPr/>
-          <p:nvPr/>
-        </p:nvSpPr>
-        <p:spPr>
-          <a:xfrm>
-            <a:off x="2103120" y="4983480"/>
-            <a:ext cx="1005840" cy="457200"/>
+          <p:cNvPr id="15" name="Text 13"/>
+          <p:cNvSpPr/>
+          <p:nvPr/>
+        </p:nvSpPr>
+        <p:spPr>
+          <a:xfrm>
+            <a:off x="2057400" y="4910328"/>
+            <a:ext cx="2697480" cy="457200"/>
           </a:xfrm>
           <a:prstGeom prst="rect">
             <a:avLst/>
@@ -9524,7 +9563,7 @@
               <a:buNone/>
             </a:pPr>
             <a:r>
-              <a:rPr lang="en-US" sz="1600" b="1" dirty="0">
+              <a:rPr lang="en-US" sz="1700" b="1" dirty="0">
                 <a:solidFill>
                   <a:srgbClr val="0E1E38"/>
                 </a:solidFill>
@@ -9532,22 +9571,22 @@
                 <a:ea typeface="Cambria" pitchFamily="34" charset="-122"/>
                 <a:cs typeface="Cambria" pitchFamily="34" charset="-120"/>
               </a:rPr>
-              <a:t>Centinaia di mln raggiungibili</a:t>
-            </a:r>
-            <a:endParaRPr lang="en-US" sz="1600" dirty="0"/>
-          </a:p>
-        </p:txBody>
-      </p:sp>
-      <p:sp>
-        <p:nvSpPr>
-          <p:cNvPr id="15" name="Text 13"/>
-          <p:cNvSpPr/>
-          <p:nvPr/>
-        </p:nvSpPr>
-        <p:spPr>
-          <a:xfrm>
-            <a:off x="2103120" y="5422392"/>
-            <a:ext cx="4114800" cy="457200"/>
+              <a:t>Centinaia di mln (beachhead 0–3 anni)</a:t>
+            </a:r>
+            <a:endParaRPr lang="en-US" sz="1700" dirty="0"/>
+          </a:p>
+        </p:txBody>
+      </p:sp>
+      <p:sp>
+        <p:nvSpPr>
+          <p:cNvPr id="16" name="Text 14"/>
+          <p:cNvSpPr/>
+          <p:nvPr/>
+        </p:nvSpPr>
+        <p:spPr>
+          <a:xfrm>
+            <a:off x="2057400" y="5367528"/>
+            <a:ext cx="2697480" cy="457200"/>
           </a:xfrm>
           <a:prstGeom prst="rect">
             <a:avLst/>
@@ -9565,13 +9604,13 @@
             <a:r>
               <a:rPr lang="en-US" sz="1250" dirty="0">
                 <a:solidFill>
-                  <a:srgbClr val="0E1E38"/>
+                  <a:srgbClr val="5A4212"/>
                 </a:solidFill>
                 <a:latin typeface="Calibri" pitchFamily="34" charset="0"/>
                 <a:ea typeface="Calibri" pitchFamily="34" charset="-122"/>
                 <a:cs typeface="Calibri" pitchFamily="34" charset="-120"/>
               </a:rPr>
-              <a:t>Target iniziale: DD B2B per reti, notai, banche, fondi</a:t>
+              <a:t>Due diligence B2B su ~720k transazioni/anno: reti, notai, banche, fondi</a:t>
             </a:r>
             <a:endParaRPr lang="en-US" sz="1250" dirty="0"/>
           </a:p>
@@ -9579,26 +9618,26 @@
       </p:sp>
       <p:sp>
         <p:nvSpPr>
-          <p:cNvPr id="16" name="Shape 14"/>
-          <p:cNvSpPr/>
-          <p:nvPr/>
-        </p:nvSpPr>
-        <p:spPr>
-          <a:xfrm>
-            <a:off x="8732520" y="2148840"/>
-            <a:ext cx="2926080" cy="3703320"/>
+          <p:cNvPr id="17" name="Shape 15"/>
+          <p:cNvSpPr/>
+          <p:nvPr/>
+        </p:nvSpPr>
+        <p:spPr>
+          <a:xfrm>
+            <a:off x="8549640" y="1965960"/>
+            <a:ext cx="3108960" cy="3931920"/>
           </a:xfrm>
           <a:prstGeom prst="roundRect">
             <a:avLst>
-              <a:gd name="adj" fmla="val 2813"/>
+              <a:gd name="adj" fmla="val 2647"/>
             </a:avLst>
           </a:prstGeom>
           <a:solidFill>
-            <a:srgbClr val="F4F7FC"/>
+            <a:srgbClr val="0E1E38"/>
           </a:solidFill>
           <a:ln w="12700">
             <a:solidFill>
-              <a:srgbClr val="D9E2EF"/>
+              <a:srgbClr val="0E1E38"/>
             </a:solidFill>
             <a:prstDash val="solid"/>
           </a:ln>
@@ -9606,14 +9645,14 @@
       </p:sp>
       <p:sp>
         <p:nvSpPr>
-          <p:cNvPr id="17" name="Text 15"/>
-          <p:cNvSpPr/>
-          <p:nvPr/>
-        </p:nvSpPr>
-        <p:spPr>
-          <a:xfrm>
-            <a:off x="8961120" y="2331720"/>
-            <a:ext cx="2514600" cy="365760"/>
+          <p:cNvPr id="18" name="Text 16"/>
+          <p:cNvSpPr/>
+          <p:nvPr/>
+        </p:nvSpPr>
+        <p:spPr>
+          <a:xfrm>
+            <a:off x="8778240" y="2148840"/>
+            <a:ext cx="2697480" cy="640080"/>
           </a:xfrm>
           <a:prstGeom prst="rect">
             <a:avLst/>
@@ -9629,201 +9668,265 @@
               <a:buNone/>
             </a:pPr>
             <a:r>
-              <a:rPr lang="en-US" sz="1500" b="1" dirty="0">
-                <a:solidFill>
-                  <a:srgbClr val="16233B"/>
+              <a:rPr lang="en-US" sz="1400" b="1" dirty="0">
+                <a:solidFill>
+                  <a:srgbClr val="E8A33D"/>
                 </a:solidFill>
                 <a:latin typeface="Cambria" pitchFamily="34" charset="0"/>
                 <a:ea typeface="Cambria" pitchFamily="34" charset="-122"/>
                 <a:cs typeface="Cambria" pitchFamily="34" charset="-120"/>
               </a:rPr>
-              <a:t>Perché si vince dal SOM</a:t>
-            </a:r>
-            <a:endParaRPr lang="en-US" sz="1500" dirty="0"/>
-          </a:p>
-        </p:txBody>
-      </p:sp>
-      <p:sp>
-        <p:nvSpPr>
-          <p:cNvPr id="18" name="Text 16"/>
-          <p:cNvSpPr/>
-          <p:nvPr/>
-        </p:nvSpPr>
-        <p:spPr>
-          <a:xfrm>
-            <a:off x="9006840" y="2788920"/>
-            <a:ext cx="2468880" cy="2926080"/>
-          </a:xfrm>
-          <a:prstGeom prst="rect">
-            <a:avLst/>
-          </a:prstGeom>
-          <a:noFill/>
-          <a:ln/>
-        </p:spPr>
-        <p:txBody>
-          <a:bodyPr wrap="square" lIns="0" tIns="0" rIns="0" bIns="0" rtlCol="0" anchor="ctr"/>
-          <a:lstStyle/>
-          <a:p>
-            <a:pPr marL="342900" indent="-342900">
+              <a:t>I numeri che reggono la tesi</a:t>
+            </a:r>
+            <a:endParaRPr lang="en-US" sz="1400" dirty="0"/>
+          </a:p>
+        </p:txBody>
+      </p:sp>
+      <p:sp>
+        <p:nvSpPr>
+          <p:cNvPr id="19" name="Text 17"/>
+          <p:cNvSpPr/>
+          <p:nvPr/>
+        </p:nvSpPr>
+        <p:spPr>
+          <a:xfrm>
+            <a:off x="8778240" y="2880360"/>
+            <a:ext cx="2697480" cy="2926080"/>
+          </a:xfrm>
+          <a:prstGeom prst="rect">
+            <a:avLst/>
+          </a:prstGeom>
+          <a:noFill/>
+          <a:ln/>
+        </p:spPr>
+        <p:txBody>
+          <a:bodyPr wrap="square" lIns="0" tIns="0" rIns="0" bIns="0" rtlCol="0" anchor="ctr"/>
+          <a:lstStyle/>
+          <a:p>
+            <a:pPr indent="0" marL="0">
               <a:spcAft>
-                <a:spcPts val="1000"/>
+                <a:spcPts val="1100"/>
               </a:spcAft>
-              <a:buSzPct val="100000"/>
-              <a:buChar char="•"/>
-            </a:pPr>
-            <a:r>
-              <a:rPr lang="en-US" sz="1300" dirty="0">
-                <a:solidFill>
-                  <a:srgbClr val="5C6C87"/>
+              <a:buNone/>
+            </a:pPr>
+            <a:r>
+              <a:rPr lang="en-US" sz="1250" b="1" dirty="0">
+                <a:solidFill>
+                  <a:srgbClr val="FFFFFF"/>
                 </a:solidFill>
                 <a:latin typeface="Calibri" pitchFamily="34" charset="0"/>
                 <a:ea typeface="Calibri" pitchFamily="34" charset="-122"/>
                 <a:cs typeface="Calibri" pitchFamily="34" charset="-120"/>
               </a:rPr>
-              <a:t>Domanda già esistente e pagante
-</a:t>
-            </a:r>
-            <a:endParaRPr lang="en-US" sz="1300" dirty="0"/>
-          </a:p>
-          <a:p>
-            <a:pPr marL="342900" indent="-342900">
+              <a:t>719.578 </a:t>
+            </a:r>
+            <a:pPr indent="0" marL="0">
               <a:spcAft>
-                <a:spcPts val="1000"/>
+                <a:spcPts val="1100"/>
               </a:spcAft>
-              <a:buSzPct val="100000"/>
-              <a:buChar char="•"/>
-            </a:pPr>
-            <a:r>
-              <a:rPr lang="en-US" sz="1300" dirty="0">
-                <a:solidFill>
-                  <a:srgbClr val="5C6C87"/>
+              <a:buNone/>
+            </a:pPr>
+            <a:r>
+              <a:rPr lang="en-US" sz="1250" dirty="0">
+                <a:solidFill>
+                  <a:srgbClr val="EAF1FA"/>
                 </a:solidFill>
                 <a:latin typeface="Calibri" pitchFamily="34" charset="0"/>
                 <a:ea typeface="Calibri" pitchFamily="34" charset="-122"/>
                 <a:cs typeface="Calibri" pitchFamily="34" charset="-120"/>
               </a:rPr>
-              <a:t>Ciclo di vendita B2B veloce
+              <a:t>compravendite residenziali (2024)
 </a:t>
             </a:r>
-            <a:endParaRPr lang="en-US" sz="1300" dirty="0"/>
-          </a:p>
-          <a:p>
-            <a:pPr marL="342900" indent="-342900">
+            <a:endParaRPr lang="en-US" sz="1250" dirty="0"/>
+          </a:p>
+          <a:p>
+            <a:pPr indent="0" marL="0">
               <a:spcAft>
-                <a:spcPts val="1000"/>
+                <a:spcPts val="1100"/>
               </a:spcAft>
-              <a:buSzPct val="100000"/>
-              <a:buChar char="•"/>
-            </a:pPr>
-            <a:r>
-              <a:rPr lang="en-US" sz="1300" dirty="0">
-                <a:solidFill>
-                  <a:srgbClr val="5C6C87"/>
+              <a:buNone/>
+            </a:pPr>
+            <a:r>
+              <a:rPr lang="en-US" sz="1250" b="1" dirty="0">
+                <a:solidFill>
+                  <a:srgbClr val="FFFFFF"/>
                 </a:solidFill>
                 <a:latin typeface="Calibri" pitchFamily="34" charset="0"/>
                 <a:ea typeface="Calibri" pitchFamily="34" charset="-122"/>
                 <a:cs typeface="Calibri" pitchFamily="34" charset="-120"/>
               </a:rPr>
-              <a:t>Ogni pratica costruisce il data-moat
-</a:t>
-            </a:r>
-            <a:endParaRPr lang="en-US" sz="1300" dirty="0"/>
-          </a:p>
-          <a:p>
-            <a:pPr marL="342900" indent="-342900">
+              <a:t>€2,8 mld </a:t>
+            </a:r>
+            <a:pPr indent="0" marL="0">
               <a:spcAft>
-                <a:spcPts val="1000"/>
+                <a:spcPts val="1100"/>
               </a:spcAft>
-              <a:buSzPct val="100000"/>
-              <a:buChar char="•"/>
-            </a:pPr>
-            <a:r>
-              <a:rPr lang="en-US" sz="1300" dirty="0">
-                <a:solidFill>
-                  <a:srgbClr val="5C6C87"/>
+              <a:buNone/>
+            </a:pPr>
+            <a:r>
+              <a:rPr lang="en-US" sz="1250" dirty="0">
+                <a:solidFill>
+                  <a:srgbClr val="EAF1FA"/>
                 </a:solidFill>
                 <a:latin typeface="Calibri" pitchFamily="34" charset="0"/>
                 <a:ea typeface="Calibri" pitchFamily="34" charset="-122"/>
                 <a:cs typeface="Calibri" pitchFamily="34" charset="-120"/>
               </a:rPr>
-              <a:t>Da lì si espande a 360°</a:t>
-            </a:r>
-            <a:endParaRPr lang="en-US" sz="1300" dirty="0"/>
-          </a:p>
-        </p:txBody>
-      </p:sp>
-      <p:sp>
-        <p:nvSpPr>
-          <p:cNvPr id="19" name="Text 17"/>
-          <p:cNvSpPr/>
-          <p:nvPr/>
-        </p:nvSpPr>
-        <p:spPr>
-          <a:xfrm>
-            <a:off x="502920" y="6035040"/>
-            <a:ext cx="7772400" cy="274320"/>
-          </a:xfrm>
-          <a:prstGeom prst="rect">
-            <a:avLst/>
-          </a:prstGeom>
-          <a:noFill/>
-          <a:ln/>
-        </p:spPr>
-        <p:txBody>
-          <a:bodyPr wrap="square" lIns="0" tIns="0" rIns="0" bIns="0" rtlCol="0" anchor="ctr"/>
-          <a:lstStyle/>
+              <a:t>ricavi intermediazione; €36 mld servizi immobiliari
+</a:t>
+            </a:r>
+            <a:endParaRPr lang="en-US" sz="1250" dirty="0"/>
+          </a:p>
           <a:p>
             <a:pPr indent="0" marL="0">
-              <a:buNone/>
-            </a:pPr>
-            <a:r>
-              <a:rPr lang="en-US" sz="1000" dirty="0">
-                <a:solidFill>
-                  <a:srgbClr val="5C6C87"/>
+              <a:spcAft>
+                <a:spcPts val="1100"/>
+              </a:spcAft>
+              <a:buNone/>
+            </a:pPr>
+            <a:r>
+              <a:rPr lang="en-US" sz="1250" b="1" dirty="0">
+                <a:solidFill>
+                  <a:srgbClr val="FFFFFF"/>
                 </a:solidFill>
                 <a:latin typeface="Calibri" pitchFamily="34" charset="0"/>
                 <a:ea typeface="Calibri" pitchFamily="34" charset="-122"/>
                 <a:cs typeface="Calibri" pitchFamily="34" charset="-120"/>
               </a:rPr>
-              <a:t>Dimensionamenti indicativi / ordine di grandezza, da validare in fase di diligence.</a:t>
-            </a:r>
-            <a:endParaRPr lang="en-US" sz="1000" dirty="0"/>
-          </a:p>
-        </p:txBody>
-      </p:sp>
-      <p:sp>
-        <p:nvSpPr>
-          <p:cNvPr id="20" name="Text 18"/>
-          <p:cNvSpPr/>
-          <p:nvPr/>
-        </p:nvSpPr>
-        <p:spPr>
-          <a:xfrm>
-            <a:off x="11338560" y="6355080"/>
-            <a:ext cx="457200" cy="274320"/>
-          </a:xfrm>
-          <a:prstGeom prst="rect">
-            <a:avLst/>
-          </a:prstGeom>
-          <a:noFill/>
-          <a:ln/>
-        </p:spPr>
-        <p:txBody>
-          <a:bodyPr wrap="square" lIns="0" tIns="0" rIns="0" bIns="0" rtlCol="0" anchor="ctr"/>
-          <a:lstStyle/>
-          <a:p>
-            <a:pPr algn="r" indent="0" marL="0">
-              <a:buNone/>
-            </a:pPr>
-            <a:r>
-              <a:rPr lang="en-US" sz="1000" dirty="0">
-                <a:solidFill>
-                  <a:srgbClr val="5C6C87"/>
+              <a:t>€85 mld </a:t>
+            </a:r>
+            <a:pPr indent="0" marL="0">
+              <a:spcAft>
+                <a:spcPts val="1100"/>
+              </a:spcAft>
+              <a:buNone/>
+            </a:pPr>
+            <a:r>
+              <a:rPr lang="en-US" sz="1250" dirty="0">
+                <a:solidFill>
+                  <a:srgbClr val="EAF1FA"/>
                 </a:solidFill>
                 <a:latin typeface="Calibri" pitchFamily="34" charset="0"/>
                 <a:ea typeface="Calibri" pitchFamily="34" charset="-122"/>
                 <a:cs typeface="Calibri" pitchFamily="34" charset="-120"/>
               </a:rPr>
+              <a:t>investimenti Case Green entro il 2030
+</a:t>
+            </a:r>
+            <a:endParaRPr lang="en-US" sz="1250" dirty="0"/>
+          </a:p>
+          <a:p>
+            <a:pPr indent="0" marL="0">
+              <a:spcAft>
+                <a:spcPts val="1100"/>
+              </a:spcAft>
+              <a:buNone/>
+            </a:pPr>
+            <a:r>
+              <a:rPr lang="en-US" sz="1250" b="1" dirty="0">
+                <a:solidFill>
+                  <a:srgbClr val="FFFFFF"/>
+                </a:solidFill>
+                <a:latin typeface="Calibri" pitchFamily="34" charset="0"/>
+                <a:ea typeface="Calibri" pitchFamily="34" charset="-122"/>
+                <a:cs typeface="Calibri" pitchFamily="34" charset="-120"/>
+              </a:rPr>
+              <a:t>~500.000 </a:t>
+            </a:r>
+            <a:pPr indent="0" marL="0">
+              <a:spcAft>
+                <a:spcPts val="1100"/>
+              </a:spcAft>
+              <a:buNone/>
+            </a:pPr>
+            <a:r>
+              <a:rPr lang="en-US" sz="1250" dirty="0">
+                <a:solidFill>
+                  <a:srgbClr val="EAF1FA"/>
+                </a:solidFill>
+                <a:latin typeface="Calibri" pitchFamily="34" charset="0"/>
+                <a:ea typeface="Calibri" pitchFamily="34" charset="-122"/>
+                <a:cs typeface="Calibri" pitchFamily="34" charset="-120"/>
+              </a:rPr>
+              <a:t>abitazioni/anno da riqualificare</a:t>
+            </a:r>
+            <a:endParaRPr lang="en-US" sz="1250" dirty="0"/>
+          </a:p>
+        </p:txBody>
+      </p:sp>
+      <p:sp>
+        <p:nvSpPr>
+          <p:cNvPr id="20" name="Text 18"/>
+          <p:cNvSpPr/>
+          <p:nvPr/>
+        </p:nvSpPr>
+        <p:spPr>
+          <a:xfrm>
+            <a:off x="502920" y="6053328"/>
+            <a:ext cx="7863840" cy="457200"/>
+          </a:xfrm>
+          <a:prstGeom prst="rect">
+            <a:avLst/>
+          </a:prstGeom>
+          <a:noFill/>
+          <a:ln/>
+        </p:spPr>
+        <p:txBody>
+          <a:bodyPr wrap="square" lIns="0" tIns="0" rIns="0" bIns="0" rtlCol="0" anchor="ctr"/>
+          <a:lstStyle/>
+          <a:p>
+            <a:pPr indent="0" marL="0">
+              <a:buNone/>
+            </a:pPr>
+            <a:r>
+              <a:rPr lang="en-US" sz="950" dirty="0">
+                <a:solidFill>
+                  <a:srgbClr val="5C6C87"/>
+                </a:solidFill>
+                <a:latin typeface="Calibri" pitchFamily="34" charset="0"/>
+                <a:ea typeface="Calibri" pitchFamily="34" charset="-122"/>
+                <a:cs typeface="Calibri" pitchFamily="34" charset="-120"/>
+              </a:rPr>
+              <a:t>Fonti: OMI–Agenzia delle Entrate (2024); Il Sole 24 Ore; ACCA/BibLus, rinnovabili.it (EPBD). SAM/SOM: stime, da validare in diligence.</a:t>
+            </a:r>
+            <a:endParaRPr lang="en-US" sz="950" dirty="0"/>
+          </a:p>
+        </p:txBody>
+      </p:sp>
+      <p:sp>
+        <p:nvSpPr>
+          <p:cNvPr id="21" name="Text 19"/>
+          <p:cNvSpPr/>
+          <p:nvPr/>
+        </p:nvSpPr>
+        <p:spPr>
+          <a:xfrm>
+            <a:off x="11338560" y="6355080"/>
+            <a:ext cx="457200" cy="274320"/>
+          </a:xfrm>
+          <a:prstGeom prst="rect">
+            <a:avLst/>
+          </a:prstGeom>
+          <a:noFill/>
+          <a:ln/>
+        </p:spPr>
+        <p:txBody>
+          <a:bodyPr wrap="square" lIns="0" tIns="0" rIns="0" bIns="0" rtlCol="0" anchor="ctr"/>
+          <a:lstStyle/>
+          <a:p>
+            <a:pPr algn="r" indent="0" marL="0">
+              <a:buNone/>
+            </a:pPr>
+            <a:r>
+              <a:rPr lang="en-US" sz="1000" dirty="0">
+                <a:solidFill>
+                  <a:srgbClr val="5C6C87"/>
+                </a:solidFill>
+                <a:latin typeface="Calibri" pitchFamily="34" charset="0"/>
+                <a:ea typeface="Calibri" pitchFamily="34" charset="-122"/>
+                <a:cs typeface="Calibri" pitchFamily="34" charset="-120"/>
+              </a:rPr>
               <a:t>07</a:t>
             </a:r>
             <a:endParaRPr lang="en-US" sz="1000" dirty="0"/>
@@ -9832,7 +9935,7 @@
       </p:sp>
       <p:sp>
         <p:nvSpPr>
-          <p:cNvPr id="21" name="Text 19"/>
+          <p:cNvPr id="22" name="Text 20"/>
           <p:cNvSpPr/>
           <p:nvPr/>
         </p:nvSpPr>
@@ -11036,7 +11139,7 @@
                 <a:ea typeface="Calibri" pitchFamily="34" charset="-122"/>
                 <a:cs typeface="Calibri" pitchFamily="34" charset="-120"/>
               </a:rPr>
-              <a:t>La EPBD impone l'adeguamento energetico di milioni di edifici entro il 2030/2033: un'ondata di ristrutturazioni forzata e finanziabile.</a:t>
+              <a:t>La EPBD (recepimento entro maggio 2026) impone l'adeguamento di ~500.000 abitazioni/anno: ~€85 mld di investimenti entro il 2030. Domanda forzata e finanziabile.</a:t>
             </a:r>
             <a:endParaRPr lang="en-US" sz="1350" dirty="0"/>
           </a:p>

</xml_diff>

<commit_message>
Add PDF export of pitch deck; fix flywheel and market slide layout
Render the deck to PDF via a Chromium/Playwright HTML pipeline (inch-for-inch
port of the pptx layout), since LibreOffice cannot convert in this environment.
Also clean up the data-flywheel into a non-overlapping quadrant layout and
shorten the SOM box text so it no longer clips, in both the pptx and HTML/PDF.

Co-Authored-By: Claude Opus 4.8 <noreply@anthropic.com>
Claude-Session: https://claude.ai/code/session_0135g8yviycycMotcppH6TXW
</commit_message>
<xml_diff>
--- a/proptech-deck/Conforme_Pitch.pptx
+++ b/proptech-deck/Conforme_Pitch.pptx
@@ -7195,8 +7195,8 @@
         </p:nvSpPr>
         <p:spPr>
           <a:xfrm>
-            <a:off x="5074920" y="3063240"/>
-            <a:ext cx="2011680" cy="2011680"/>
+            <a:off x="5276088" y="2971800"/>
+            <a:ext cx="1645920" cy="1645920"/>
           </a:xfrm>
           <a:prstGeom prst="ellipse">
             <a:avLst/>
@@ -7215,8 +7215,8 @@
         </p:nvSpPr>
         <p:spPr>
           <a:xfrm>
-            <a:off x="5074920" y="3063240"/>
-            <a:ext cx="2011680" cy="2011680"/>
+            <a:off x="5276088" y="2971800"/>
+            <a:ext cx="1645920" cy="1645920"/>
           </a:xfrm>
           <a:prstGeom prst="rect">
             <a:avLst/>
@@ -7232,7 +7232,7 @@
               <a:buNone/>
             </a:pPr>
             <a:r>
-              <a:rPr lang="en-US" sz="1600" b="1" dirty="0">
+              <a:rPr lang="en-US" sz="1500" b="1" dirty="0">
                 <a:solidFill>
                   <a:srgbClr val="0E1E38"/>
                 </a:solidFill>
@@ -7242,14 +7242,14 @@
               </a:rPr>
               <a:t>DATI</a:t>
             </a:r>
-            <a:endParaRPr lang="en-US" sz="1600" dirty="0"/>
+            <a:endParaRPr lang="en-US" sz="1500" dirty="0"/>
           </a:p>
           <a:p>
             <a:pPr algn="ctr" indent="0" marL="0">
               <a:buNone/>
             </a:pPr>
             <a:r>
-              <a:rPr lang="en-US" sz="1600" b="1" dirty="0">
+              <a:rPr lang="en-US" sz="1500" b="1" dirty="0">
                 <a:solidFill>
                   <a:srgbClr val="0E1E38"/>
                 </a:solidFill>
@@ -7259,7 +7259,7 @@
               </a:rPr>
               <a:t>PROPRIETARI</a:t>
             </a:r>
-            <a:endParaRPr lang="en-US" sz="1600" dirty="0"/>
+            <a:endParaRPr lang="en-US" sz="1500" dirty="0"/>
           </a:p>
         </p:txBody>
       </p:sp>
@@ -7271,12 +7271,12 @@
         </p:nvSpPr>
         <p:spPr>
           <a:xfrm>
-            <a:off x="4023360" y="1874520"/>
-            <a:ext cx="2743200" cy="1005840"/>
+            <a:off x="2331720" y="2331720"/>
+            <a:ext cx="2743200" cy="960120"/>
           </a:xfrm>
           <a:prstGeom prst="roundRect">
             <a:avLst>
-              <a:gd name="adj" fmla="val 8182"/>
+              <a:gd name="adj" fmla="val 8571"/>
             </a:avLst>
           </a:prstGeom>
           <a:solidFill>
@@ -7298,8 +7298,8 @@
         </p:nvSpPr>
         <p:spPr>
           <a:xfrm>
-            <a:off x="4160520" y="1874520"/>
-            <a:ext cx="2468880" cy="1005840"/>
+            <a:off x="2468880" y="2331720"/>
+            <a:ext cx="2468880" cy="960120"/>
           </a:xfrm>
           <a:prstGeom prst="rect">
             <a:avLst/>
@@ -7337,12 +7337,12 @@
         </p:nvSpPr>
         <p:spPr>
           <a:xfrm>
-            <a:off x="8275320" y="2880360"/>
-            <a:ext cx="2743200" cy="1005840"/>
+            <a:off x="7086600" y="2331720"/>
+            <a:ext cx="2743200" cy="960120"/>
           </a:xfrm>
           <a:prstGeom prst="roundRect">
             <a:avLst>
-              <a:gd name="adj" fmla="val 8182"/>
+              <a:gd name="adj" fmla="val 8571"/>
             </a:avLst>
           </a:prstGeom>
           <a:solidFill>
@@ -7364,8 +7364,8 @@
         </p:nvSpPr>
         <p:spPr>
           <a:xfrm>
-            <a:off x="8412480" y="2880360"/>
-            <a:ext cx="2468880" cy="1005840"/>
+            <a:off x="7223760" y="2331720"/>
+            <a:ext cx="2468880" cy="960120"/>
           </a:xfrm>
           <a:prstGeom prst="rect">
             <a:avLst/>
@@ -7403,12 +7403,12 @@
         </p:nvSpPr>
         <p:spPr>
           <a:xfrm>
-            <a:off x="4023360" y="4251960"/>
-            <a:ext cx="2743200" cy="1005840"/>
+            <a:off x="7086600" y="4480560"/>
+            <a:ext cx="2743200" cy="960120"/>
           </a:xfrm>
           <a:prstGeom prst="roundRect">
             <a:avLst>
-              <a:gd name="adj" fmla="val 8182"/>
+              <a:gd name="adj" fmla="val 8571"/>
             </a:avLst>
           </a:prstGeom>
           <a:solidFill>
@@ -7430,8 +7430,8 @@
         </p:nvSpPr>
         <p:spPr>
           <a:xfrm>
-            <a:off x="4160520" y="4251960"/>
-            <a:ext cx="2468880" cy="1005840"/>
+            <a:off x="7223760" y="4480560"/>
+            <a:ext cx="2468880" cy="960120"/>
           </a:xfrm>
           <a:prstGeom prst="rect">
             <a:avLst/>
@@ -7469,12 +7469,12 @@
         </p:nvSpPr>
         <p:spPr>
           <a:xfrm>
-            <a:off x="960120" y="2880360"/>
-            <a:ext cx="2743200" cy="1005840"/>
+            <a:off x="2331720" y="4480560"/>
+            <a:ext cx="2743200" cy="960120"/>
           </a:xfrm>
           <a:prstGeom prst="roundRect">
             <a:avLst>
-              <a:gd name="adj" fmla="val 8182"/>
+              <a:gd name="adj" fmla="val 8571"/>
             </a:avLst>
           </a:prstGeom>
           <a:solidFill>
@@ -7496,8 +7496,8 @@
         </p:nvSpPr>
         <p:spPr>
           <a:xfrm>
-            <a:off x="1097280" y="2880360"/>
-            <a:ext cx="2468880" cy="1005840"/>
+            <a:off x="2468880" y="4480560"/>
+            <a:ext cx="2468880" cy="960120"/>
           </a:xfrm>
           <a:prstGeom prst="rect">
             <a:avLst/>
@@ -7529,7 +7529,87 @@
       </p:sp>
       <p:sp>
         <p:nvSpPr>
-          <p:cNvPr id="14" name="Text 12"/>
+          <p:cNvPr id="14" name="Shape 12"/>
+          <p:cNvSpPr/>
+          <p:nvPr/>
+        </p:nvSpPr>
+        <p:spPr>
+          <a:xfrm>
+            <a:off x="5897880" y="2651760"/>
+            <a:ext cx="310896" cy="219456"/>
+          </a:xfrm>
+          <a:prstGeom prst="rightArrow">
+            <a:avLst/>
+          </a:prstGeom>
+          <a:solidFill>
+            <a:srgbClr val="E8A33D"/>
+          </a:solidFill>
+          <a:ln/>
+        </p:spPr>
+      </p:sp>
+      <p:sp>
+        <p:nvSpPr>
+          <p:cNvPr id="15" name="Shape 13"/>
+          <p:cNvSpPr/>
+          <p:nvPr/>
+        </p:nvSpPr>
+        <p:spPr>
+          <a:xfrm rot="5400000">
+            <a:off x="8366760" y="3611880"/>
+            <a:ext cx="310896" cy="219456"/>
+          </a:xfrm>
+          <a:prstGeom prst="rightArrow">
+            <a:avLst/>
+          </a:prstGeom>
+          <a:solidFill>
+            <a:srgbClr val="E8A33D"/>
+          </a:solidFill>
+          <a:ln/>
+        </p:spPr>
+      </p:sp>
+      <p:sp>
+        <p:nvSpPr>
+          <p:cNvPr id="16" name="Shape 14"/>
+          <p:cNvSpPr/>
+          <p:nvPr/>
+        </p:nvSpPr>
+        <p:spPr>
+          <a:xfrm rot="10800000">
+            <a:off x="5897880" y="4800600"/>
+            <a:ext cx="310896" cy="219456"/>
+          </a:xfrm>
+          <a:prstGeom prst="rightArrow">
+            <a:avLst/>
+          </a:prstGeom>
+          <a:solidFill>
+            <a:srgbClr val="E8A33D"/>
+          </a:solidFill>
+          <a:ln/>
+        </p:spPr>
+      </p:sp>
+      <p:sp>
+        <p:nvSpPr>
+          <p:cNvPr id="17" name="Shape 15"/>
+          <p:cNvSpPr/>
+          <p:nvPr/>
+        </p:nvSpPr>
+        <p:spPr>
+          <a:xfrm rot="16200000">
+            <a:off x="3611880" y="3611880"/>
+            <a:ext cx="310896" cy="219456"/>
+          </a:xfrm>
+          <a:prstGeom prst="rightArrow">
+            <a:avLst/>
+          </a:prstGeom>
+          <a:solidFill>
+            <a:srgbClr val="E8A33D"/>
+          </a:solidFill>
+          <a:ln/>
+        </p:spPr>
+      </p:sp>
+      <p:sp>
+        <p:nvSpPr>
+          <p:cNvPr id="18" name="Text 16"/>
           <p:cNvSpPr/>
           <p:nvPr/>
         </p:nvSpPr>
@@ -7568,7 +7648,7 @@
       </p:sp>
       <p:sp>
         <p:nvSpPr>
-          <p:cNvPr id="15" name="Text 13"/>
+          <p:cNvPr id="19" name="Text 17"/>
           <p:cNvSpPr/>
           <p:nvPr/>
         </p:nvSpPr>
@@ -7607,7 +7687,7 @@
       </p:sp>
       <p:sp>
         <p:nvSpPr>
-          <p:cNvPr id="16" name="Text 14"/>
+          <p:cNvPr id="20" name="Text 18"/>
           <p:cNvSpPr/>
           <p:nvPr/>
         </p:nvSpPr>
@@ -9571,7 +9651,7 @@
                 <a:ea typeface="Cambria" pitchFamily="34" charset="-122"/>
                 <a:cs typeface="Cambria" pitchFamily="34" charset="-120"/>
               </a:rPr>
-              <a:t>Centinaia di mln (beachhead 0–3 anni)</a:t>
+              <a:t>Centinaia di mln</a:t>
             </a:r>
             <a:endParaRPr lang="en-US" sz="1700" dirty="0"/>
           </a:p>
@@ -9610,7 +9690,7 @@
                 <a:ea typeface="Calibri" pitchFamily="34" charset="-122"/>
                 <a:cs typeface="Calibri" pitchFamily="34" charset="-120"/>
               </a:rPr>
-              <a:t>Due diligence B2B su ~720k transazioni/anno: reti, notai, banche, fondi</a:t>
+              <a:t>Beachhead 0–3 anni: DD B2B per reti, notai, banche, fondi</a:t>
             </a:r>
             <a:endParaRPr lang="en-US" sz="1250" dirty="0"/>
           </a:p>

</xml_diff>

<commit_message>
Remove Universe/SAE/Skylabs references from the deck
Reframe the 'why us' slide generically (agentic platform in production +
enterprise-AI competence, no brand names) and drop the Skylabs mentions
from the title and closing bylines.

Co-Authored-By: Claude Opus 4.8 <noreply@anthropic.com>
Claude-Session: https://claude.ai/code/session_0135g8yviycycMotcppH6TXW
</commit_message>
<xml_diff>
--- a/proptech-deck/Conforme_Pitch.pptx
+++ b/proptech-deck/Conforme_Pitch.pptx
@@ -2916,7 +2916,7 @@
                 <a:ea typeface="Calibri" pitchFamily="34" charset="-122"/>
                 <a:cs typeface="Calibri" pitchFamily="34" charset="-120"/>
               </a:rPr>
-              <a:t>Pitch per investitore  ·  Luca Martino · Skylabs</a:t>
+              <a:t>Pitch per investitore  ·  Luca Martino</a:t>
             </a:r>
             <a:endParaRPr lang="en-US" sz="1300" dirty="0"/>
           </a:p>
@@ -6422,7 +6422,7 @@
                 <a:ea typeface="Cambria" pitchFamily="34" charset="-122"/>
                 <a:cs typeface="Cambria" pitchFamily="34" charset="-120"/>
               </a:rPr>
-              <a:t>Universe</a:t>
+              <a:t>Piattaforma agentica pronta</a:t>
             </a:r>
             <a:endParaRPr lang="en-US" sz="1800" dirty="0"/>
           </a:p>
@@ -6461,7 +6461,7 @@
                 <a:ea typeface="Calibri" pitchFamily="34" charset="-122"/>
                 <a:cs typeface="Calibri" pitchFamily="34" charset="-120"/>
               </a:rPr>
-              <a:t>La piattaforma agentica di Skylabs: l'infrastruttura AI è già in produzione, non da inventare.</a:t>
+              <a:t>L'infrastruttura AI agentica è già in produzione: non la costruiamo da zero.</a:t>
             </a:r>
             <a:endParaRPr lang="en-US" sz="1300" dirty="0"/>
           </a:p>
@@ -6527,7 +6527,7 @@
                 <a:ea typeface="Cambria" pitchFamily="34" charset="-122"/>
                 <a:cs typeface="Cambria" pitchFamily="34" charset="-120"/>
               </a:rPr>
-              <a:t>Skylabs / SAE</a:t>
+              <a:t>Competenza AI enterprise</a:t>
             </a:r>
             <a:endParaRPr lang="en-US" sz="1800" dirty="0"/>
           </a:p>
@@ -6566,7 +6566,7 @@
                 <a:ea typeface="Calibri" pitchFamily="34" charset="-122"/>
                 <a:cs typeface="Calibri" pitchFamily="34" charset="-120"/>
               </a:rPr>
-              <a:t>Competenza consolidata di AI enterprise e integrazione su processi complessi.</a:t>
+              <a:t>Esperienza consolidata di AI enterprise e integrazione su processi complessi.</a:t>
             </a:r>
             <a:endParaRPr lang="en-US" sz="1300" dirty="0"/>
           </a:p>
@@ -6903,7 +6903,7 @@
                 <a:ea typeface="Cambria" pitchFamily="34" charset="-122"/>
                 <a:cs typeface="Cambria" pitchFamily="34" charset="-120"/>
               </a:rPr>
-              <a:t>Universe · piattaforma agentica</a:t>
+              <a:t>Piattaforma agentica in produzione</a:t>
             </a:r>
             <a:endParaRPr lang="en-US" sz="1400" dirty="0"/>
           </a:p>
@@ -6969,7 +6969,7 @@
                 <a:ea typeface="Calibri" pitchFamily="34" charset="-122"/>
                 <a:cs typeface="Calibri" pitchFamily="34" charset="-120"/>
               </a:rPr>
-              <a:t>Skylabs / SAE · AI enterprise</a:t>
+              <a:t>Competenza AI enterprise</a:t>
             </a:r>
             <a:endParaRPr lang="en-US" sz="1300" dirty="0"/>
           </a:p>
@@ -8411,7 +8411,7 @@
                 <a:ea typeface="Calibri" pitchFamily="34" charset="-122"/>
                 <a:cs typeface="Calibri" pitchFamily="34" charset="-120"/>
               </a:rPr>
-              <a:t>Luca Martino  ·  Skylabs  ·  luca.martino@skylabs.it</a:t>
+              <a:t>Luca Martino</a:t>
             </a:r>
             <a:endParaRPr lang="en-US" sz="1300" dirty="0"/>
           </a:p>

</xml_diff>